<commit_message>
US 114050: built-in lesson decks on Course material tab; fix pptx corruption
Root cause: generators shared one SHADOW options object which PptxGenJS
mutates in place, compounding EMU multiplications into invalid exponential
attribute values (schema-invalid decks, PowerPoint '[Repaired]' prompts).

- all make-*.mjs generators now pass a fresh shadow copy per shape
- regenerated every pptx deck; all open cleanly in PowerPoint now
- converted the four 114050 lesson decks to PDF
- BUILTIN_DECKS in Course.tsx: 114050 always shows its lesson slides
  in the Course material tab ahead of shared uploads

Co-authored-by: Copilot <223556219+Copilot@users.noreply.github.com>
</commit_message>
<xml_diff>
--- a/public/downloads/How-a-PSU-Works-Rectifier-and-MOSFET.pptx
+++ b/public/downloads/How-a-PSU-Works-Rectifier-and-MOSFET.pptx
@@ -5301,9 +5301,9 @@
             <a:prstDash val="solid"/>
           </a:ln>
           <a:effectLst>
-            <a:outerShdw sx="100000" sy="100000" kx="0" ky="0" algn="bl" rotWithShape="0" blurRad="5.644197821471012e+115" dist="1.6126279489917177e+115" dir="5.526847993018334e+135">
+            <a:outerShdw sx="100000" sy="100000" kx="0" ky="0" algn="bl" rotWithShape="0" blurRad="88900" dist="25400" dir="5400000">
               <a:srgbClr val="9AB4CC">
-                <a:alpha val="2.9999999999999994e+139"/>
+                <a:alpha val="30000"/>
               </a:srgbClr>
             </a:outerShdw>
           </a:effectLst>
@@ -5443,9 +5443,9 @@
             <a:prstDash val="solid"/>
           </a:ln>
           <a:effectLst>
-            <a:outerShdw sx="100000" sy="100000" kx="0" ky="0" algn="bl" rotWithShape="0" blurRad="7.168131233268186e+119" dist="2.0480374952194813e+119" dir="3.3161087958110005e+140">
+            <a:outerShdw sx="100000" sy="100000" kx="0" ky="0" algn="bl" rotWithShape="0" blurRad="88900" dist="25400" dir="5400000">
               <a:srgbClr val="9AB4CC">
-                <a:alpha val="2.9999999999999996e+144"/>
+                <a:alpha val="30000"/>
               </a:srgbClr>
             </a:outerShdw>
           </a:effectLst>
@@ -5996,9 +5996,9 @@
             <a:prstDash val="solid"/>
           </a:ln>
           <a:effectLst>
-            <a:outerShdw sx="100000" sy="100000" kx="0" ky="0" algn="bl" rotWithShape="0" blurRad="9.103526666250596e+123" dist="2.6010076189287412e+123" dir="1.9896652774866004e+145">
+            <a:outerShdw sx="100000" sy="100000" kx="0" ky="0" algn="bl" rotWithShape="0" blurRad="88900" dist="25400" dir="5400000">
               <a:srgbClr val="9AB4CC">
-                <a:alpha val="2.9999999999999996e+149"/>
+                <a:alpha val="30000"/>
               </a:srgbClr>
             </a:outerShdw>
           </a:effectLst>
@@ -6168,9 +6168,9 @@
             <a:prstDash val="solid"/>
           </a:ln>
           <a:effectLst>
-            <a:outerShdw sx="100000" sy="100000" kx="0" ky="0" algn="bl" rotWithShape="0" blurRad="1.1561478866138256e+128" dist="3.303279676039501e+127" dir="1.1937991664919603e+150">
+            <a:outerShdw sx="100000" sy="100000" kx="0" ky="0" algn="bl" rotWithShape="0" blurRad="88900" dist="25400" dir="5400000">
               <a:srgbClr val="9AB4CC">
-                <a:alpha val="2.9999999999999997e+154"/>
+                <a:alpha val="30000"/>
               </a:srgbClr>
             </a:outerShdw>
           </a:effectLst>
@@ -6333,9 +6333,9 @@
             <a:prstDash val="solid"/>
           </a:ln>
           <a:effectLst>
-            <a:outerShdw sx="100000" sy="100000" kx="0" ky="0" algn="bl" rotWithShape="0" blurRad="1.4683078159995586e+132" dist="4.195165188570166e+131" dir="7.162794998951762e+154">
+            <a:outerShdw sx="100000" sy="100000" kx="0" ky="0" algn="bl" rotWithShape="0" blurRad="88900" dist="25400" dir="5400000">
               <a:srgbClr val="9AB4CC">
-                <a:alpha val="2.9999999999999998e+159"/>
+                <a:alpha val="30000"/>
               </a:srgbClr>
             </a:outerShdw>
           </a:effectLst>
@@ -6498,9 +6498,9 @@
             <a:prstDash val="solid"/>
           </a:ln>
           <a:effectLst>
-            <a:outerShdw sx="100000" sy="100000" kx="0" ky="0" algn="bl" rotWithShape="0" blurRad="1.8647509263194394e+136" dist="5.327859789484111e+135" dir="4.297676999371057e+159">
+            <a:outerShdw sx="100000" sy="100000" kx="0" ky="0" algn="bl" rotWithShape="0" blurRad="88900" dist="25400" dir="5400000">
               <a:srgbClr val="9AB4CC">
-                <a:alpha val="3e+164"/>
+                <a:alpha val="30000"/>
               </a:srgbClr>
             </a:outerShdw>
           </a:effectLst>
@@ -7336,9 +7336,9 @@
             <a:prstDash val="solid"/>
           </a:ln>
           <a:effectLst>
-            <a:outerShdw sx="100000" sy="100000" kx="0" ky="0" algn="bl" rotWithShape="0" blurRad="2.368233676425688e+140" dist="6.766381932644821e+139" dir="2.5786061996226343e+164">
+            <a:outerShdw sx="100000" sy="100000" kx="0" ky="0" algn="bl" rotWithShape="0" blurRad="88900" dist="25400" dir="5400000">
               <a:srgbClr val="9AB4CC">
-                <a:alpha val="3e+169"/>
+                <a:alpha val="30000"/>
               </a:srgbClr>
             </a:outerShdw>
           </a:effectLst>
@@ -7508,9 +7508,9 @@
             <a:prstDash val="solid"/>
           </a:ln>
           <a:effectLst>
-            <a:outerShdw sx="100000" sy="100000" kx="0" ky="0" algn="bl" rotWithShape="0" blurRad="3.0076567690606238e+144" dist="8.593305054458923e+143" dir="1.5471637197735807e+169">
+            <a:outerShdw sx="100000" sy="100000" kx="0" ky="0" algn="bl" rotWithShape="0" blurRad="88900" dist="25400" dir="5400000">
               <a:srgbClr val="9AB4CC">
-                <a:alpha val="3e+174"/>
+                <a:alpha val="30000"/>
               </a:srgbClr>
             </a:outerShdw>
           </a:effectLst>
@@ -7634,9 +7634,9 @@
             <a:prstDash val="solid"/>
           </a:ln>
           <a:effectLst>
-            <a:outerShdw sx="100000" sy="100000" kx="0" ky="0" algn="bl" rotWithShape="0" blurRad="3.819724096706992e+148" dist="1.0913497419162833e+148" dir="9.282982318641485e+173">
+            <a:outerShdw sx="100000" sy="100000" kx="0" ky="0" algn="bl" rotWithShape="0" blurRad="88900" dist="25400" dir="5400000">
               <a:srgbClr val="9AB4CC">
-                <a:alpha val="3e+179"/>
+                <a:alpha val="30000"/>
               </a:srgbClr>
             </a:outerShdw>
           </a:effectLst>
@@ -7760,9 +7760,9 @@
             <a:prstDash val="solid"/>
           </a:ln>
           <a:effectLst>
-            <a:outerShdw sx="100000" sy="100000" kx="0" ky="0" algn="bl" rotWithShape="0" blurRad="4.85104960281788e+152" dist="1.38601417223368e+152" dir="5.569789391184891e+178">
+            <a:outerShdw sx="100000" sy="100000" kx="0" ky="0" algn="bl" rotWithShape="0" blurRad="88900" dist="25400" dir="5400000">
               <a:srgbClr val="9AB4CC">
-                <a:alpha val="3e+184"/>
+                <a:alpha val="30000"/>
               </a:srgbClr>
             </a:outerShdw>
           </a:effectLst>
@@ -7886,9 +7886,9 @@
             <a:prstDash val="solid"/>
           </a:ln>
           <a:effectLst>
-            <a:outerShdw sx="100000" sy="100000" kx="0" ky="0" algn="bl" rotWithShape="0" blurRad="6.160832995578707e+156" dist="1.7602379987367734e+156" dir="3.3418736347109347e+183">
+            <a:outerShdw sx="100000" sy="100000" kx="0" ky="0" algn="bl" rotWithShape="0" blurRad="88900" dist="25400" dir="5400000">
               <a:srgbClr val="9AB4CC">
-                <a:alpha val="3e+189"/>
+                <a:alpha val="30000"/>
               </a:srgbClr>
             </a:outerShdw>
           </a:effectLst>
@@ -8341,9 +8341,9 @@
             <a:prstDash val="solid"/>
           </a:ln>
           <a:effectLst>
-            <a:outerShdw sx="100000" sy="100000" kx="0" ky="0" algn="bl" rotWithShape="0" blurRad="7.824257904384958e+160" dist="2.235502258395702e+160" dir="2.0051241808265608e+188">
+            <a:outerShdw sx="100000" sy="100000" kx="0" ky="0" algn="bl" rotWithShape="0" blurRad="88900" dist="25400" dir="5400000">
               <a:srgbClr val="9AB4CC">
-                <a:alpha val="2.9999999999999997e+194"/>
+                <a:alpha val="30000"/>
               </a:srgbClr>
             </a:outerShdw>
           </a:effectLst>
@@ -8513,9 +8513,9 @@
             <a:prstDash val="solid"/>
           </a:ln>
           <a:effectLst>
-            <a:outerShdw sx="100000" sy="100000" kx="0" ky="0" algn="bl" rotWithShape="0" blurRad="9.936807538568897e+164" dist="2.8390878681625417e+164" dir="1.2030745084959364e+193">
+            <a:outerShdw sx="100000" sy="100000" kx="0" ky="0" algn="bl" rotWithShape="0" blurRad="88900" dist="25400" dir="5400000">
               <a:srgbClr val="9AB4CC">
-                <a:alpha val="2.9999999999999997e+199"/>
+                <a:alpha val="30000"/>
               </a:srgbClr>
             </a:outerShdw>
           </a:effectLst>
@@ -8639,9 +8639,9 @@
             <a:prstDash val="solid"/>
           </a:ln>
           <a:effectLst>
-            <a:outerShdw sx="100000" sy="100000" kx="0" ky="0" algn="bl" rotWithShape="0" blurRad="1.26197455739825e+169" dist="3.605641592566428e+168" dir="7.218447050975619e+197">
+            <a:outerShdw sx="100000" sy="100000" kx="0" ky="0" algn="bl" rotWithShape="0" blurRad="88900" dist="25400" dir="5400000">
               <a:srgbClr val="9AB4CC">
-                <a:alpha val="3e+204"/>
+                <a:alpha val="30000"/>
               </a:srgbClr>
             </a:outerShdw>
           </a:effectLst>
@@ -8765,9 +8765,9 @@
             <a:prstDash val="solid"/>
           </a:ln>
           <a:effectLst>
-            <a:outerShdw sx="100000" sy="100000" kx="0" ky="0" algn="bl" rotWithShape="0" blurRad="1.6027076878957775e+173" dist="4.579164822559364e+172" dir="4.3310682305853715e+202">
+            <a:outerShdw sx="100000" sy="100000" kx="0" ky="0" algn="bl" rotWithShape="0" blurRad="88900" dist="25400" dir="5400000">
               <a:srgbClr val="9AB4CC">
-                <a:alpha val="3e+209"/>
+                <a:alpha val="30000"/>
               </a:srgbClr>
             </a:outerShdw>
           </a:effectLst>
@@ -8891,9 +8891,9 @@
             <a:prstDash val="solid"/>
           </a:ln>
           <a:effectLst>
-            <a:outerShdw sx="100000" sy="100000" kx="0" ky="0" algn="bl" rotWithShape="0" blurRad="2.0354387636276376e+177" dist="5.815539324650392e+176" dir="2.598640938351223e+207">
+            <a:outerShdw sx="100000" sy="100000" kx="0" ky="0" algn="bl" rotWithShape="0" blurRad="88900" dist="25400" dir="5400000">
               <a:srgbClr val="9AB4CC">
-                <a:alpha val="2.9999999999999996e+214"/>
+                <a:alpha val="30000"/>
               </a:srgbClr>
             </a:outerShdw>
           </a:effectLst>
@@ -9346,9 +9346,9 @@
             <a:prstDash val="solid"/>
           </a:ln>
           <a:effectLst>
-            <a:outerShdw sx="100000" sy="100000" kx="0" ky="0" algn="bl" rotWithShape="0" blurRad="2.5850072298071e+181" dist="7.385734942305998e+180" dir="1.5591845630107338e+212">
+            <a:outerShdw sx="100000" sy="100000" kx="0" ky="0" algn="bl" rotWithShape="0" blurRad="88900" dist="25400" dir="5400000">
               <a:srgbClr val="9AB4CC">
-                <a:alpha val="3e+219"/>
+                <a:alpha val="30000"/>
               </a:srgbClr>
             </a:outerShdw>
           </a:effectLst>
@@ -9518,9 +9518,9 @@
             <a:prstDash val="solid"/>
           </a:ln>
           <a:effectLst>
-            <a:outerShdw sx="100000" sy="100000" kx="0" ky="0" algn="bl" rotWithShape="0" blurRad="3.282959181855017e+185" dist="9.379883376728618e+184" dir="9.355107378064403e+216">
+            <a:outerShdw sx="100000" sy="100000" kx="0" ky="0" algn="bl" rotWithShape="0" blurRad="88900" dist="25400" dir="5400000">
               <a:srgbClr val="9AB4CC">
-                <a:alpha val="2.9999999999999997e+224"/>
+                <a:alpha val="30000"/>
               </a:srgbClr>
             </a:outerShdw>
           </a:effectLst>
@@ -9644,9 +9644,9 @@
             <a:prstDash val="solid"/>
           </a:ln>
           <a:effectLst>
-            <a:outerShdw sx="100000" sy="100000" kx="0" ky="0" algn="bl" rotWithShape="0" blurRad="4.1693581609558713e+189" dist="1.1912451888445345e+189" dir="5.613064426838642e+221">
+            <a:outerShdw sx="100000" sy="100000" kx="0" ky="0" algn="bl" rotWithShape="0" blurRad="88900" dist="25400" dir="5400000">
               <a:srgbClr val="9AB4CC">
-                <a:alpha val="2.9999999999999994e+229"/>
+                <a:alpha val="30000"/>
               </a:srgbClr>
             </a:outerShdw>
           </a:effectLst>
@@ -9770,9 +9770,9 @@
             <a:prstDash val="solid"/>
           </a:ln>
           <a:effectLst>
-            <a:outerShdw sx="100000" sy="100000" kx="0" ky="0" algn="bl" rotWithShape="0" blurRad="5.295084864413956e+193" dist="1.5128813898325588e+193" dir="3.367838656103185e+226">
+            <a:outerShdw sx="100000" sy="100000" kx="0" ky="0" algn="bl" rotWithShape="0" blurRad="88900" dist="25400" dir="5400000">
               <a:srgbClr val="9AB4CC">
-                <a:alpha val="2.9999999999999995e+234"/>
+                <a:alpha val="30000"/>
               </a:srgbClr>
             </a:outerShdw>
           </a:effectLst>
@@ -9896,9 +9896,9 @@
             <a:prstDash val="solid"/>
           </a:ln>
           <a:effectLst>
-            <a:outerShdw sx="100000" sy="100000" kx="0" ky="0" algn="bl" rotWithShape="0" blurRad="6.724757777805725e+197" dist="1.9213593650873497e+197" dir="2.020703193661911e+231">
+            <a:outerShdw sx="100000" sy="100000" kx="0" ky="0" algn="bl" rotWithShape="0" blurRad="88900" dist="25400" dir="5400000">
               <a:srgbClr val="9AB4CC">
-                <a:alpha val="2.9999999999999994e+239"/>
+                <a:alpha val="30000"/>
               </a:srgbClr>
             </a:outerShdw>
           </a:effectLst>
@@ -10351,9 +10351,9 @@
             <a:prstDash val="solid"/>
           </a:ln>
           <a:effectLst>
-            <a:outerShdw sx="100000" sy="100000" kx="0" ky="0" algn="bl" rotWithShape="0" blurRad="8.54044237781327e+201" dist="2.440126393660934e+201" dir="1.2124219161971466e+236">
+            <a:outerShdw sx="100000" sy="100000" kx="0" ky="0" algn="bl" rotWithShape="0" blurRad="88900" dist="25400" dir="5400000">
               <a:srgbClr val="9AB4CC">
-                <a:alpha val="2.999999999999999e+244"/>
+                <a:alpha val="30000"/>
               </a:srgbClr>
             </a:outerShdw>
           </a:effectLst>
@@ -10518,9 +10518,9 @@
             <a:prstDash val="solid"/>
           </a:ln>
           <a:effectLst>
-            <a:outerShdw sx="100000" sy="100000" kx="0" ky="0" algn="bl" rotWithShape="0" blurRad="1.0846361819822852e+206" dist="3.0989605199493864e+205" dir="7.27453149718288e+240">
+            <a:outerShdw sx="100000" sy="100000" kx="0" ky="0" algn="bl" rotWithShape="0" blurRad="88900" dist="25400" dir="5400000">
               <a:srgbClr val="9AB4CC">
-                <a:alpha val="2.999999999999999e+249"/>
+                <a:alpha val="30000"/>
               </a:srgbClr>
             </a:outerShdw>
           </a:effectLst>
@@ -10660,9 +10660,9 @@
             <a:prstDash val="solid"/>
           </a:ln>
           <a:effectLst>
-            <a:outerShdw sx="100000" sy="100000" kx="0" ky="0" algn="bl" rotWithShape="0" blurRad="1.3774879511175023e+210" dist="3.9356798603357206e+209" dir="4.364718898309728e+245">
+            <a:outerShdw sx="100000" sy="100000" kx="0" ky="0" algn="bl" rotWithShape="0" blurRad="88900" dist="25400" dir="5400000">
               <a:srgbClr val="9AB4CC">
-                <a:alpha val="2.999999999999999e+254"/>
+                <a:alpha val="30000"/>
               </a:srgbClr>
             </a:outerShdw>
           </a:effectLst>
@@ -10832,9 +10832,9 @@
             <a:prstDash val="solid"/>
           </a:ln>
           <a:effectLst>
-            <a:outerShdw sx="100000" sy="100000" kx="0" ky="0" algn="bl" rotWithShape="0" blurRad="1.7494096979192279e+214" dist="4.9983134226263654e+213" dir="2.6188313389858368e+250">
+            <a:outerShdw sx="100000" sy="100000" kx="0" ky="0" algn="bl" rotWithShape="0" blurRad="88900" dist="25400" dir="5400000">
               <a:srgbClr val="9AB4CC">
-                <a:alpha val="2.999999999999999e+259"/>
+                <a:alpha val="30000"/>
               </a:srgbClr>
             </a:outerShdw>
           </a:effectLst>
@@ -10958,9 +10958,9 @@
             <a:prstDash val="solid"/>
           </a:ln>
           <a:effectLst>
-            <a:outerShdw sx="100000" sy="100000" kx="0" ky="0" algn="bl" rotWithShape="0" blurRad="2.2217503163574194e+218" dist="6.347858046735484e+217" dir="1.571298803391502e+255">
+            <a:outerShdw sx="100000" sy="100000" kx="0" ky="0" algn="bl" rotWithShape="0" blurRad="88900" dist="25400" dir="5400000">
               <a:srgbClr val="9AB4CC">
-                <a:alpha val="2.999999999999999e+264"/>
+                <a:alpha val="30000"/>
               </a:srgbClr>
             </a:outerShdw>
           </a:effectLst>
@@ -11084,9 +11084,9 @@
             <a:prstDash val="solid"/>
           </a:ln>
           <a:effectLst>
-            <a:outerShdw sx="100000" sy="100000" kx="0" ky="0" algn="bl" rotWithShape="0" blurRad="2.8216229017739227e+222" dist="8.061779719354066e+221" dir="9.427792820349012e+259">
+            <a:outerShdw sx="100000" sy="100000" kx="0" ky="0" algn="bl" rotWithShape="0" blurRad="88900" dist="25400" dir="5400000">
               <a:srgbClr val="9AB4CC">
-                <a:alpha val="2.999999999999999e+269"/>
+                <a:alpha val="30000"/>
               </a:srgbClr>
             </a:outerShdw>
           </a:effectLst>
@@ -11210,9 +11210,9 @@
             <a:prstDash val="solid"/>
           </a:ln>
           <a:effectLst>
-            <a:outerShdw sx="100000" sy="100000" kx="0" ky="0" algn="bl" rotWithShape="0" blurRad="3.5834610852528816e+226" dist="1.0238460243579663e+226" dir="5.656675692209407e+264">
+            <a:outerShdw sx="100000" sy="100000" kx="0" ky="0" algn="bl" rotWithShape="0" blurRad="88900" dist="25400" dir="5400000">
               <a:srgbClr val="9AB4CC">
-                <a:alpha val="2.9999999999999988e+274"/>
+                <a:alpha val="30000"/>
               </a:srgbClr>
             </a:outerShdw>
           </a:effectLst>
@@ -11336,9 +11336,9 @@
             <a:prstDash val="solid"/>
           </a:ln>
           <a:effectLst>
-            <a:outerShdw sx="100000" sy="100000" kx="0" ky="0" algn="bl" rotWithShape="0" blurRad="4.550995578271159e+230" dist="1.3002844509346172e+230" dir="3.3940054153256444e+269">
+            <a:outerShdw sx="100000" sy="100000" kx="0" ky="0" algn="bl" rotWithShape="0" blurRad="88900" dist="25400" dir="5400000">
               <a:srgbClr val="9AB4CC">
-                <a:alpha val="2.999999999999999e+279"/>
+                <a:alpha val="30000"/>
               </a:srgbClr>
             </a:outerShdw>
           </a:effectLst>
@@ -11855,9 +11855,9 @@
             <a:prstDash val="solid"/>
           </a:ln>
           <a:effectLst>
-            <a:outerShdw sx="100000" sy="100000" kx="0" ky="0" algn="bl" rotWithShape="0" blurRad="5.7797643844043726e+234" dist="1.6513612526869638e+234" dir="2.0364032491953868e+274">
+            <a:outerShdw sx="100000" sy="100000" kx="0" ky="0" algn="bl" rotWithShape="0" blurRad="88900" dist="25400" dir="5400000">
               <a:srgbClr val="9AB4CC">
-                <a:alpha val="2.999999999999999e+284"/>
+                <a:alpha val="30000"/>
               </a:srgbClr>
             </a:outerShdw>
           </a:effectLst>
@@ -12022,9 +12022,9 @@
             <a:prstDash val="solid"/>
           </a:ln>
           <a:effectLst>
-            <a:outerShdw sx="100000" sy="100000" kx="0" ky="0" algn="bl" rotWithShape="0" blurRad="7.340300768193554e+238" dist="2.097228790912444e+238" dir="1.221841949517232e+279">
+            <a:outerShdw sx="100000" sy="100000" kx="0" ky="0" algn="bl" rotWithShape="0" blurRad="88900" dist="25400" dir="5400000">
               <a:srgbClr val="9AB4CC">
-                <a:alpha val="2.999999999999999e+289"/>
+                <a:alpha val="30000"/>
               </a:srgbClr>
             </a:outerShdw>
           </a:effectLst>
@@ -12189,9 +12189,9 @@
             <a:prstDash val="solid"/>
           </a:ln>
           <a:effectLst>
-            <a:outerShdw sx="100000" sy="100000" kx="0" ky="0" algn="bl" rotWithShape="0" blurRad="9.322181975605814e+242" dist="2.663480564458804e+242" dir="7.331051697103393e+283">
+            <a:outerShdw sx="100000" sy="100000" kx="0" ky="0" algn="bl" rotWithShape="0" blurRad="88900" dist="25400" dir="5400000">
               <a:srgbClr val="9AB4CC">
-                <a:alpha val="2.999999999999999e+294"/>
+                <a:alpha val="30000"/>
               </a:srgbClr>
             </a:outerShdw>
           </a:effectLst>
@@ -12644,9 +12644,9 @@
             <a:prstDash val="solid"/>
           </a:ln>
           <a:effectLst>
-            <a:outerShdw sx="100000" sy="100000" kx="0" ky="0" algn="bl" rotWithShape="0" blurRad="1.1839171109019383e+247" dist="3.3826203168626813e+246" dir="4.3986310182620354e+288">
+            <a:outerShdw sx="100000" sy="100000" kx="0" ky="0" algn="bl" rotWithShape="0" blurRad="88900" dist="25400" dir="5400000">
               <a:srgbClr val="9AB4CC">
-                <a:alpha val="2.999999999999999e+299"/>
+                <a:alpha val="30000"/>
               </a:srgbClr>
             </a:outerShdw>
           </a:effectLst>
@@ -12811,9 +12811,9 @@
             <a:prstDash val="solid"/>
           </a:ln>
           <a:effectLst>
-            <a:outerShdw sx="100000" sy="100000" kx="0" ky="0" algn="bl" rotWithShape="0" blurRad="1.5035747308454617e+251" dist="4.295927802415605e+250" dir="2.6391786109572213e+293">
+            <a:outerShdw sx="100000" sy="100000" kx="0" ky="0" algn="bl" rotWithShape="0" blurRad="88900" dist="25400" dir="5400000">
               <a:srgbClr val="9AB4CC">
-                <a:alpha val="2.999999999999999e+304"/>
+                <a:alpha val="30000"/>
               </a:srgbClr>
             </a:outerShdw>
           </a:effectLst>
@@ -12978,9 +12978,9 @@
             <a:prstDash val="solid"/>
           </a:ln>
           <a:effectLst>
-            <a:outerShdw sx="100000" sy="100000" kx="0" ky="0" algn="bl" rotWithShape="0" blurRad="1.9095399081737364e+255" dist="5.455828309067819e+254" dir="1.5835071665743328e+298">
+            <a:outerShdw sx="100000" sy="100000" kx="0" ky="0" algn="bl" rotWithShape="0" blurRad="88900" dist="25400" dir="5400000">
               <a:srgbClr val="9AB4CC">
-                <a:alpha val="Infinity"/>
+                <a:alpha val="30000"/>
               </a:srgbClr>
             </a:outerShdw>
           </a:effectLst>
@@ -13145,9 +13145,9 @@
             <a:prstDash val="solid"/>
           </a:ln>
           <a:effectLst>
-            <a:outerShdw sx="100000" sy="100000" kx="0" ky="0" algn="bl" rotWithShape="0" blurRad="2.425115683380645e+259" dist="6.928901952516129e+258" dir="9.501042999445996e+302">
+            <a:outerShdw sx="100000" sy="100000" kx="0" ky="0" algn="bl" rotWithShape="0" blurRad="88900" dist="25400" dir="5400000">
               <a:srgbClr val="9AB4CC">
-                <a:alpha val="Infinity"/>
+                <a:alpha val="30000"/>
               </a:srgbClr>
             </a:outerShdw>
           </a:effectLst>
@@ -13719,9 +13719,9 @@
             <a:prstDash val="solid"/>
           </a:ln>
           <a:effectLst>
-            <a:outerShdw sx="100000" sy="100000" kx="0" ky="0" algn="bl" rotWithShape="0" blurRad="3.079896917893419e+263" dist="8.799705479695485e+262" dir="5.700625799667598e+307">
+            <a:outerShdw sx="100000" sy="100000" kx="0" ky="0" algn="bl" rotWithShape="0" blurRad="88900" dist="25400" dir="5400000">
               <a:srgbClr val="9AB4CC">
-                <a:alpha val="Infinity"/>
+                <a:alpha val="30000"/>
               </a:srgbClr>
             </a:outerShdw>
           </a:effectLst>
@@ -13886,9 +13886,9 @@
             <a:prstDash val="solid"/>
           </a:ln>
           <a:effectLst>
-            <a:outerShdw sx="100000" sy="100000" kx="0" ky="0" algn="bl" rotWithShape="0" blurRad="3.9114690857246423e+267" dist="1.1175625959213265e+267" dir="Infinity">
+            <a:outerShdw sx="100000" sy="100000" kx="0" ky="0" algn="bl" rotWithShape="0" blurRad="88900" dist="25400" dir="5400000">
               <a:srgbClr val="9AB4CC">
-                <a:alpha val="Infinity"/>
+                <a:alpha val="30000"/>
               </a:srgbClr>
             </a:outerShdw>
           </a:effectLst>
@@ -14547,9 +14547,9 @@
             <a:prstDash val="solid"/>
           </a:ln>
           <a:effectLst>
-            <a:outerShdw sx="100000" sy="100000" kx="0" ky="0" algn="bl" rotWithShape="0" blurRad="1129030000" dist="322580000" dir="324000000000">
+            <a:outerShdw sx="100000" sy="100000" kx="0" ky="0" algn="bl" rotWithShape="0" blurRad="88900" dist="25400" dir="5400000">
               <a:srgbClr val="9AB4CC">
-                <a:alpha val="3000000000"/>
+                <a:alpha val="30000"/>
               </a:srgbClr>
             </a:outerShdw>
           </a:effectLst>
@@ -14714,9 +14714,9 @@
             <a:prstDash val="solid"/>
           </a:ln>
           <a:effectLst>
-            <a:outerShdw sx="100000" sy="100000" kx="0" ky="0" algn="bl" rotWithShape="0" blurRad="14338681000000" dist="4096766000000" dir="19440000000000000">
+            <a:outerShdw sx="100000" sy="100000" kx="0" ky="0" algn="bl" rotWithShape="0" blurRad="88900" dist="25400" dir="5400000">
               <a:srgbClr val="9AB4CC">
-                <a:alpha val="300000000000000"/>
+                <a:alpha val="30000"/>
               </a:srgbClr>
             </a:outerShdw>
           </a:effectLst>
@@ -14881,9 +14881,9 @@
             <a:prstDash val="solid"/>
           </a:ln>
           <a:effectLst>
-            <a:outerShdw sx="100000" sy="100000" kx="0" ky="0" algn="bl" rotWithShape="0" blurRad="182101248700000000" dist="52028928200000000" dir="1.1664e+21">
+            <a:outerShdw sx="100000" sy="100000" kx="0" ky="0" algn="bl" rotWithShape="0" blurRad="88900" dist="25400" dir="5400000">
               <a:srgbClr val="9AB4CC">
-                <a:alpha val="30000000000000000000"/>
+                <a:alpha val="30000"/>
               </a:srgbClr>
             </a:outerShdw>
           </a:effectLst>
@@ -15023,9 +15023,9 @@
             <a:prstDash val="solid"/>
           </a:ln>
           <a:effectLst>
-            <a:outerShdw sx="100000" sy="100000" kx="0" ky="0" algn="bl" rotWithShape="0" blurRad="2.31268585849e+21" dist="660767388140000000000" dir="6.9984e+25">
+            <a:outerShdw sx="100000" sy="100000" kx="0" ky="0" algn="bl" rotWithShape="0" blurRad="88900" dist="25400" dir="5400000">
               <a:srgbClr val="9AB4CC">
-                <a:alpha val="3e+24"/>
+                <a:alpha val="30000"/>
               </a:srgbClr>
             </a:outerShdw>
           </a:effectLst>
@@ -15165,9 +15165,9 @@
             <a:prstDash val="solid"/>
           </a:ln>
           <a:effectLst>
-            <a:outerShdw sx="100000" sy="100000" kx="0" ky="0" algn="bl" rotWithShape="0" blurRad="2.9371110402823e+25" dist="8.391745829378e+24" dir="4.19904e+30">
+            <a:outerShdw sx="100000" sy="100000" kx="0" ky="0" algn="bl" rotWithShape="0" blurRad="88900" dist="25400" dir="5400000">
               <a:srgbClr val="9AB4CC">
-                <a:alpha val="3e+29"/>
+                <a:alpha val="30000"/>
               </a:srgbClr>
             </a:outerShdw>
           </a:effectLst>
@@ -15307,9 +15307,9 @@
             <a:prstDash val="solid"/>
           </a:ln>
           <a:effectLst>
-            <a:outerShdw sx="100000" sy="100000" kx="0" ky="0" algn="bl" rotWithShape="0" blurRad="3.730131021158521e+29" dist="1.0657517203310059e+29" dir="2.519424e+35">
+            <a:outerShdw sx="100000" sy="100000" kx="0" ky="0" algn="bl" rotWithShape="0" blurRad="88900" dist="25400" dir="5400000">
               <a:srgbClr val="9AB4CC">
-                <a:alpha val="2.9999999999999997e+34"/>
+                <a:alpha val="30000"/>
               </a:srgbClr>
             </a:outerShdw>
           </a:effectLst>
@@ -15449,9 +15449,9 @@
             <a:prstDash val="solid"/>
           </a:ln>
           <a:effectLst>
-            <a:outerShdw sx="100000" sy="100000" kx="0" ky="0" algn="bl" rotWithShape="0" blurRad="4.737266396871321e+33" dist="1.3535046848203775e+33" dir="1.5116544e+40">
+            <a:outerShdw sx="100000" sy="100000" kx="0" ky="0" algn="bl" rotWithShape="0" blurRad="88900" dist="25400" dir="5400000">
               <a:srgbClr val="9AB4CC">
-                <a:alpha val="3e+39"/>
+                <a:alpha val="30000"/>
               </a:srgbClr>
             </a:outerShdw>
           </a:effectLst>
@@ -15799,9 +15799,9 @@
             <a:prstDash val="solid"/>
           </a:ln>
           <a:effectLst>
-            <a:outerShdw sx="100000" sy="100000" kx="0" ky="0" algn="bl" rotWithShape="0" blurRad="4.9675657388702955e+271" dist="1.4193044968200846e+271" dir="Infinity">
+            <a:outerShdw sx="100000" sy="100000" kx="0" ky="0" algn="bl" rotWithShape="0" blurRad="88900" dist="25400" dir="5400000">
               <a:srgbClr val="9AB4CC">
-                <a:alpha val="Infinity"/>
+                <a:alpha val="30000"/>
               </a:srgbClr>
             </a:outerShdw>
           </a:effectLst>
@@ -15941,9 +15941,9 @@
             <a:prstDash val="solid"/>
           </a:ln>
           <a:effectLst>
-            <a:outerShdw sx="100000" sy="100000" kx="0" ky="0" algn="bl" rotWithShape="0" blurRad="6.308808488365275e+275" dist="1.8025167109615074e+275" dir="Infinity">
+            <a:outerShdw sx="100000" sy="100000" kx="0" ky="0" algn="bl" rotWithShape="0" blurRad="88900" dist="25400" dir="5400000">
               <a:srgbClr val="9AB4CC">
-                <a:alpha val="Infinity"/>
+                <a:alpha val="30000"/>
               </a:srgbClr>
             </a:outerShdw>
           </a:effectLst>
@@ -16435,9 +16435,9 @@
             <a:prstDash val="solid"/>
           </a:ln>
           <a:effectLst>
-            <a:outerShdw sx="100000" sy="100000" kx="0" ky="0" algn="bl" rotWithShape="0" blurRad="8.012186780223899e+279" dist="2.2891962229211143e+279" dir="Infinity">
+            <a:outerShdw sx="100000" sy="100000" kx="0" ky="0" algn="bl" rotWithShape="0" blurRad="88900" dist="25400" dir="5400000">
               <a:srgbClr val="9AB4CC">
-                <a:alpha val="Infinity"/>
+                <a:alpha val="30000"/>
               </a:srgbClr>
             </a:outerShdw>
           </a:effectLst>
@@ -16602,9 +16602,9 @@
             <a:prstDash val="solid"/>
           </a:ln>
           <a:effectLst>
-            <a:outerShdw sx="100000" sy="100000" kx="0" ky="0" algn="bl" rotWithShape="0" blurRad="1.0175477210884352e+284" dist="2.9072792031098153e+283" dir="Infinity">
+            <a:outerShdw sx="100000" sy="100000" kx="0" ky="0" algn="bl" rotWithShape="0" blurRad="88900" dist="25400" dir="5400000">
               <a:srgbClr val="9AB4CC">
-                <a:alpha val="Infinity"/>
+                <a:alpha val="30000"/>
               </a:srgbClr>
             </a:outerShdw>
           </a:effectLst>
@@ -16769,9 +16769,9 @@
             <a:prstDash val="solid"/>
           </a:ln>
           <a:effectLst>
-            <a:outerShdw sx="100000" sy="100000" kx="0" ky="0" algn="bl" rotWithShape="0" blurRad="1.2922856057823127e+288" dist="3.6922445879494656e+287" dir="Infinity">
+            <a:outerShdw sx="100000" sy="100000" kx="0" ky="0" algn="bl" rotWithShape="0" blurRad="88900" dist="25400" dir="5400000">
               <a:srgbClr val="9AB4CC">
-                <a:alpha val="Infinity"/>
+                <a:alpha val="30000"/>
               </a:srgbClr>
             </a:outerShdw>
           </a:effectLst>
@@ -17263,9 +17263,9 @@
             <a:prstDash val="solid"/>
           </a:ln>
           <a:effectLst>
-            <a:outerShdw sx="100000" sy="100000" kx="0" ky="0" algn="bl" rotWithShape="0" blurRad="1.6412027193435371e+292" dist="4.6891506266958215e+291" dir="Infinity">
+            <a:outerShdw sx="100000" sy="100000" kx="0" ky="0" algn="bl" rotWithShape="0" blurRad="88900" dist="25400" dir="5400000">
               <a:srgbClr val="9AB4CC">
-                <a:alpha val="Infinity"/>
+                <a:alpha val="30000"/>
               </a:srgbClr>
             </a:outerShdw>
           </a:effectLst>
@@ -17391,9 +17391,9 @@
             <a:prstDash val="solid"/>
           </a:ln>
           <a:effectLst>
-            <a:outerShdw sx="100000" sy="100000" kx="0" ky="0" algn="bl" rotWithShape="0" blurRad="2.0843274535662923e+296" dist="5.955221295903693e+295" dir="Infinity">
+            <a:outerShdw sx="100000" sy="100000" kx="0" ky="0" algn="bl" rotWithShape="0" blurRad="88900" dist="25400" dir="5400000">
               <a:srgbClr val="9AB4CC">
-                <a:alpha val="Infinity"/>
+                <a:alpha val="30000"/>
               </a:srgbClr>
             </a:outerShdw>
           </a:effectLst>
@@ -17519,9 +17519,9 @@
             <a:prstDash val="solid"/>
           </a:ln>
           <a:effectLst>
-            <a:outerShdw sx="100000" sy="100000" kx="0" ky="0" algn="bl" rotWithShape="0" blurRad="2.647095866029191e+300" dist="7.56313104579769e+299" dir="Infinity">
+            <a:outerShdw sx="100000" sy="100000" kx="0" ky="0" algn="bl" rotWithShape="0" blurRad="88900" dist="25400" dir="5400000">
               <a:srgbClr val="9AB4CC">
-                <a:alpha val="Infinity"/>
+                <a:alpha val="30000"/>
               </a:srgbClr>
             </a:outerShdw>
           </a:effectLst>
@@ -17647,9 +17647,9 @@
             <a:prstDash val="solid"/>
           </a:ln>
           <a:effectLst>
-            <a:outerShdw sx="100000" sy="100000" kx="0" ky="0" algn="bl" rotWithShape="0" blurRad="3.3618117498570727e+304" dist="9.605176428163068e+303" dir="Infinity">
+            <a:outerShdw sx="100000" sy="100000" kx="0" ky="0" algn="bl" rotWithShape="0" blurRad="88900" dist="25400" dir="5400000">
               <a:srgbClr val="9AB4CC">
-                <a:alpha val="Infinity"/>
+                <a:alpha val="30000"/>
               </a:srgbClr>
             </a:outerShdw>
           </a:effectLst>
@@ -17775,9 +17775,9 @@
             <a:prstDash val="solid"/>
           </a:ln>
           <a:effectLst>
-            <a:outerShdw sx="100000" sy="100000" kx="0" ky="0" algn="bl" rotWithShape="0" blurRad="Infinity" dist="1.2198574063767096e+308" dir="Infinity">
+            <a:outerShdw sx="100000" sy="100000" kx="0" ky="0" algn="bl" rotWithShape="0" blurRad="88900" dist="25400" dir="5400000">
               <a:srgbClr val="9AB4CC">
-                <a:alpha val="Infinity"/>
+                <a:alpha val="30000"/>
               </a:srgbClr>
             </a:outerShdw>
           </a:effectLst>
@@ -17878,9 +17878,9 @@
             <a:prstDash val="solid"/>
           </a:ln>
           <a:effectLst>
-            <a:outerShdw sx="100000" sy="100000" kx="0" ky="0" algn="bl" rotWithShape="0" blurRad="Infinity" dist="Infinity" dir="Infinity">
+            <a:outerShdw sx="100000" sy="100000" kx="0" ky="0" algn="bl" rotWithShape="0" blurRad="88900" dist="25400" dir="5400000">
               <a:srgbClr val="9AB4CC">
-                <a:alpha val="Infinity"/>
+                <a:alpha val="30000"/>
               </a:srgbClr>
             </a:outerShdw>
           </a:effectLst>
@@ -18006,9 +18006,9 @@
             <a:prstDash val="solid"/>
           </a:ln>
           <a:effectLst>
-            <a:outerShdw sx="100000" sy="100000" kx="0" ky="0" algn="bl" rotWithShape="0" blurRad="Infinity" dist="Infinity" dir="Infinity">
+            <a:outerShdw sx="100000" sy="100000" kx="0" ky="0" algn="bl" rotWithShape="0" blurRad="88900" dist="25400" dir="5400000">
               <a:srgbClr val="9AB4CC">
-                <a:alpha val="Infinity"/>
+                <a:alpha val="30000"/>
               </a:srgbClr>
             </a:outerShdw>
           </a:effectLst>
@@ -18134,9 +18134,9 @@
             <a:prstDash val="solid"/>
           </a:ln>
           <a:effectLst>
-            <a:outerShdw sx="100000" sy="100000" kx="0" ky="0" algn="bl" rotWithShape="0" blurRad="Infinity" dist="Infinity" dir="Infinity">
+            <a:outerShdw sx="100000" sy="100000" kx="0" ky="0" algn="bl" rotWithShape="0" blurRad="88900" dist="25400" dir="5400000">
               <a:srgbClr val="9AB4CC">
-                <a:alpha val="Infinity"/>
+                <a:alpha val="30000"/>
               </a:srgbClr>
             </a:outerShdw>
           </a:effectLst>
@@ -18262,9 +18262,9 @@
             <a:prstDash val="solid"/>
           </a:ln>
           <a:effectLst>
-            <a:outerShdw sx="100000" sy="100000" kx="0" ky="0" algn="bl" rotWithShape="0" blurRad="Infinity" dist="Infinity" dir="Infinity">
+            <a:outerShdw sx="100000" sy="100000" kx="0" ky="0" algn="bl" rotWithShape="0" blurRad="88900" dist="25400" dir="5400000">
               <a:srgbClr val="9AB4CC">
-                <a:alpha val="Infinity"/>
+                <a:alpha val="30000"/>
               </a:srgbClr>
             </a:outerShdw>
           </a:effectLst>
@@ -18390,9 +18390,9 @@
             <a:prstDash val="solid"/>
           </a:ln>
           <a:effectLst>
-            <a:outerShdw sx="100000" sy="100000" kx="0" ky="0" algn="bl" rotWithShape="0" blurRad="Infinity" dist="Infinity" dir="Infinity">
+            <a:outerShdw sx="100000" sy="100000" kx="0" ky="0" algn="bl" rotWithShape="0" blurRad="88900" dist="25400" dir="5400000">
               <a:srgbClr val="9AB4CC">
-                <a:alpha val="Infinity"/>
+                <a:alpha val="30000"/>
               </a:srgbClr>
             </a:outerShdw>
           </a:effectLst>
@@ -18701,9 +18701,9 @@
             <a:prstDash val="solid"/>
           </a:ln>
           <a:effectLst>
-            <a:outerShdw sx="100000" sy="100000" kx="0" ky="0" algn="bl" rotWithShape="0" blurRad="Infinity" dist="Infinity" dir="Infinity">
+            <a:outerShdw sx="100000" sy="100000" kx="0" ky="0" algn="bl" rotWithShape="0" blurRad="88900" dist="25400" dir="5400000">
               <a:srgbClr val="9AB4CC">
-                <a:alpha val="Infinity"/>
+                <a:alpha val="30000"/>
               </a:srgbClr>
             </a:outerShdw>
           </a:effectLst>
@@ -18843,9 +18843,9 @@
             <a:prstDash val="solid"/>
           </a:ln>
           <a:effectLst>
-            <a:outerShdw sx="100000" sy="100000" kx="0" ky="0" algn="bl" rotWithShape="0" blurRad="Infinity" dist="Infinity" dir="Infinity">
+            <a:outerShdw sx="100000" sy="100000" kx="0" ky="0" algn="bl" rotWithShape="0" blurRad="88900" dist="25400" dir="5400000">
               <a:srgbClr val="9AB4CC">
-                <a:alpha val="Infinity"/>
+                <a:alpha val="30000"/>
               </a:srgbClr>
             </a:outerShdw>
           </a:effectLst>
@@ -18985,9 +18985,9 @@
             <a:prstDash val="solid"/>
           </a:ln>
           <a:effectLst>
-            <a:outerShdw sx="100000" sy="100000" kx="0" ky="0" algn="bl" rotWithShape="0" blurRad="Infinity" dist="Infinity" dir="Infinity">
+            <a:outerShdw sx="100000" sy="100000" kx="0" ky="0" algn="bl" rotWithShape="0" blurRad="88900" dist="25400" dir="5400000">
               <a:srgbClr val="9AB4CC">
-                <a:alpha val="Infinity"/>
+                <a:alpha val="30000"/>
               </a:srgbClr>
             </a:outerShdw>
           </a:effectLst>
@@ -19127,9 +19127,9 @@
             <a:prstDash val="solid"/>
           </a:ln>
           <a:effectLst>
-            <a:outerShdw sx="100000" sy="100000" kx="0" ky="0" algn="bl" rotWithShape="0" blurRad="Infinity" dist="Infinity" dir="Infinity">
+            <a:outerShdw sx="100000" sy="100000" kx="0" ky="0" algn="bl" rotWithShape="0" blurRad="88900" dist="25400" dir="5400000">
               <a:srgbClr val="9AB4CC">
-                <a:alpha val="Infinity"/>
+                <a:alpha val="30000"/>
               </a:srgbClr>
             </a:outerShdw>
           </a:effectLst>
@@ -19269,9 +19269,9 @@
             <a:prstDash val="solid"/>
           </a:ln>
           <a:effectLst>
-            <a:outerShdw sx="100000" sy="100000" kx="0" ky="0" algn="bl" rotWithShape="0" blurRad="Infinity" dist="Infinity" dir="Infinity">
+            <a:outerShdw sx="100000" sy="100000" kx="0" ky="0" algn="bl" rotWithShape="0" blurRad="88900" dist="25400" dir="5400000">
               <a:srgbClr val="9AB4CC">
-                <a:alpha val="Infinity"/>
+                <a:alpha val="30000"/>
               </a:srgbClr>
             </a:outerShdw>
           </a:effectLst>
@@ -20361,9 +20361,9 @@
             <a:prstDash val="solid"/>
           </a:ln>
           <a:effectLst>
-            <a:outerShdw sx="100000" sy="100000" kx="0" ky="0" algn="bl" rotWithShape="0" blurRad="Infinity" dist="Infinity" dir="Infinity">
+            <a:outerShdw sx="100000" sy="100000" kx="0" ky="0" algn="bl" rotWithShape="0" blurRad="88900" dist="25400" dir="5400000">
               <a:srgbClr val="9AB4CC">
-                <a:alpha val="Infinity"/>
+                <a:alpha val="30000"/>
               </a:srgbClr>
             </a:outerShdw>
           </a:effectLst>
@@ -20503,9 +20503,9 @@
             <a:prstDash val="solid"/>
           </a:ln>
           <a:effectLst>
-            <a:outerShdw sx="100000" sy="100000" kx="0" ky="0" algn="bl" rotWithShape="0" blurRad="Infinity" dist="Infinity" dir="Infinity">
+            <a:outerShdw sx="100000" sy="100000" kx="0" ky="0" algn="bl" rotWithShape="0" blurRad="88900" dist="25400" dir="5400000">
               <a:srgbClr val="9AB4CC">
-                <a:alpha val="Infinity"/>
+                <a:alpha val="30000"/>
               </a:srgbClr>
             </a:outerShdw>
           </a:effectLst>
@@ -20645,9 +20645,9 @@
             <a:prstDash val="solid"/>
           </a:ln>
           <a:effectLst>
-            <a:outerShdw sx="100000" sy="100000" kx="0" ky="0" algn="bl" rotWithShape="0" blurRad="Infinity" dist="Infinity" dir="Infinity">
+            <a:outerShdw sx="100000" sy="100000" kx="0" ky="0" algn="bl" rotWithShape="0" blurRad="88900" dist="25400" dir="5400000">
               <a:srgbClr val="9AB4CC">
-                <a:alpha val="Infinity"/>
+                <a:alpha val="30000"/>
               </a:srgbClr>
             </a:outerShdw>
           </a:effectLst>
@@ -20995,9 +20995,9 @@
             <a:prstDash val="solid"/>
           </a:ln>
           <a:effectLst>
-            <a:outerShdw sx="100000" sy="100000" kx="0" ky="0" algn="bl" rotWithShape="0" blurRad="Infinity" dist="Infinity" dir="Infinity">
+            <a:outerShdw sx="100000" sy="100000" kx="0" ky="0" algn="bl" rotWithShape="0" blurRad="88900" dist="25400" dir="5400000">
               <a:srgbClr val="9AB4CC">
-                <a:alpha val="Infinity"/>
+                <a:alpha val="30000"/>
               </a:srgbClr>
             </a:outerShdw>
           </a:effectLst>
@@ -21162,9 +21162,9 @@
             <a:prstDash val="solid"/>
           </a:ln>
           <a:effectLst>
-            <a:outerShdw sx="100000" sy="100000" kx="0" ky="0" algn="bl" rotWithShape="0" blurRad="Infinity" dist="Infinity" dir="Infinity">
+            <a:outerShdw sx="100000" sy="100000" kx="0" ky="0" algn="bl" rotWithShape="0" blurRad="88900" dist="25400" dir="5400000">
               <a:srgbClr val="9AB4CC">
-                <a:alpha val="Infinity"/>
+                <a:alpha val="30000"/>
               </a:srgbClr>
             </a:outerShdw>
           </a:effectLst>
@@ -21748,9 +21748,9 @@
             <a:prstDash val="solid"/>
           </a:ln>
           <a:effectLst>
-            <a:outerShdw sx="100000" sy="100000" kx="0" ky="0" algn="bl" rotWithShape="0" blurRad="Infinity" dist="Infinity" dir="Infinity">
+            <a:outerShdw sx="100000" sy="100000" kx="0" ky="0" algn="bl" rotWithShape="0" blurRad="88900" dist="25400" dir="5400000">
               <a:srgbClr val="9AB4CC">
-                <a:alpha val="Infinity"/>
+                <a:alpha val="30000"/>
               </a:srgbClr>
             </a:outerShdw>
           </a:effectLst>
@@ -21915,9 +21915,9 @@
             <a:prstDash val="solid"/>
           </a:ln>
           <a:effectLst>
-            <a:outerShdw sx="100000" sy="100000" kx="0" ky="0" algn="bl" rotWithShape="0" blurRad="Infinity" dist="Infinity" dir="Infinity">
+            <a:outerShdw sx="100000" sy="100000" kx="0" ky="0" algn="bl" rotWithShape="0" blurRad="88900" dist="25400" dir="5400000">
               <a:srgbClr val="9AB4CC">
-                <a:alpha val="Infinity"/>
+                <a:alpha val="30000"/>
               </a:srgbClr>
             </a:outerShdw>
           </a:effectLst>
@@ -22680,9 +22680,9 @@
             <a:prstDash val="solid"/>
           </a:ln>
           <a:effectLst>
-            <a:outerShdw sx="100000" sy="100000" kx="0" ky="0" algn="bl" rotWithShape="0" blurRad="Infinity" dist="Infinity" dir="Infinity">
+            <a:outerShdw sx="100000" sy="100000" kx="0" ky="0" algn="bl" rotWithShape="0" blurRad="88900" dist="25400" dir="5400000">
               <a:srgbClr val="9AB4CC">
-                <a:alpha val="Infinity"/>
+                <a:alpha val="30000"/>
               </a:srgbClr>
             </a:outerShdw>
           </a:effectLst>
@@ -22847,9 +22847,9 @@
             <a:prstDash val="solid"/>
           </a:ln>
           <a:effectLst>
-            <a:outerShdw sx="100000" sy="100000" kx="0" ky="0" algn="bl" rotWithShape="0" blurRad="Infinity" dist="Infinity" dir="Infinity">
+            <a:outerShdw sx="100000" sy="100000" kx="0" ky="0" algn="bl" rotWithShape="0" blurRad="88900" dist="25400" dir="5400000">
               <a:srgbClr val="9AB4CC">
-                <a:alpha val="Infinity"/>
+                <a:alpha val="30000"/>
               </a:srgbClr>
             </a:outerShdw>
           </a:effectLst>
@@ -23014,9 +23014,9 @@
             <a:prstDash val="solid"/>
           </a:ln>
           <a:effectLst>
-            <a:outerShdw sx="100000" sy="100000" kx="0" ky="0" algn="bl" rotWithShape="0" blurRad="Infinity" dist="Infinity" dir="Infinity">
+            <a:outerShdw sx="100000" sy="100000" kx="0" ky="0" algn="bl" rotWithShape="0" blurRad="88900" dist="25400" dir="5400000">
               <a:srgbClr val="9AB4CC">
-                <a:alpha val="Infinity"/>
+                <a:alpha val="30000"/>
               </a:srgbClr>
             </a:outerShdw>
           </a:effectLst>
@@ -23181,9 +23181,9 @@
             <a:prstDash val="solid"/>
           </a:ln>
           <a:effectLst>
-            <a:outerShdw sx="100000" sy="100000" kx="0" ky="0" algn="bl" rotWithShape="0" blurRad="Infinity" dist="Infinity" dir="Infinity">
+            <a:outerShdw sx="100000" sy="100000" kx="0" ky="0" algn="bl" rotWithShape="0" blurRad="88900" dist="25400" dir="5400000">
               <a:srgbClr val="9AB4CC">
-                <a:alpha val="Infinity"/>
+                <a:alpha val="30000"/>
               </a:srgbClr>
             </a:outerShdw>
           </a:effectLst>
@@ -23636,9 +23636,9 @@
             <a:prstDash val="solid"/>
           </a:ln>
           <a:effectLst>
-            <a:outerShdw sx="100000" sy="100000" kx="0" ky="0" algn="bl" rotWithShape="0" blurRad="Infinity" dist="Infinity" dir="Infinity">
+            <a:outerShdw sx="100000" sy="100000" kx="0" ky="0" algn="bl" rotWithShape="0" blurRad="88900" dist="25400" dir="5400000">
               <a:srgbClr val="9AB4CC">
-                <a:alpha val="Infinity"/>
+                <a:alpha val="30000"/>
               </a:srgbClr>
             </a:outerShdw>
           </a:effectLst>
@@ -23764,9 +23764,9 @@
             <a:prstDash val="solid"/>
           </a:ln>
           <a:effectLst>
-            <a:outerShdw sx="100000" sy="100000" kx="0" ky="0" algn="bl" rotWithShape="0" blurRad="Infinity" dist="Infinity" dir="Infinity">
+            <a:outerShdw sx="100000" sy="100000" kx="0" ky="0" algn="bl" rotWithShape="0" blurRad="88900" dist="25400" dir="5400000">
               <a:srgbClr val="9AB4CC">
-                <a:alpha val="Infinity"/>
+                <a:alpha val="30000"/>
               </a:srgbClr>
             </a:outerShdw>
           </a:effectLst>
@@ -23892,9 +23892,9 @@
             <a:prstDash val="solid"/>
           </a:ln>
           <a:effectLst>
-            <a:outerShdw sx="100000" sy="100000" kx="0" ky="0" algn="bl" rotWithShape="0" blurRad="Infinity" dist="Infinity" dir="Infinity">
+            <a:outerShdw sx="100000" sy="100000" kx="0" ky="0" algn="bl" rotWithShape="0" blurRad="88900" dist="25400" dir="5400000">
               <a:srgbClr val="9AB4CC">
-                <a:alpha val="Infinity"/>
+                <a:alpha val="30000"/>
               </a:srgbClr>
             </a:outerShdw>
           </a:effectLst>
@@ -24035,9 +24035,9 @@
             <a:prstDash val="solid"/>
           </a:ln>
           <a:effectLst>
-            <a:outerShdw sx="100000" sy="100000" kx="0" ky="0" algn="bl" rotWithShape="0" blurRad="Infinity" dist="Infinity" dir="Infinity">
+            <a:outerShdw sx="100000" sy="100000" kx="0" ky="0" algn="bl" rotWithShape="0" blurRad="88900" dist="25400" dir="5400000">
               <a:srgbClr val="9AB4CC">
-                <a:alpha val="Infinity"/>
+                <a:alpha val="30000"/>
               </a:srgbClr>
             </a:outerShdw>
           </a:effectLst>
@@ -25089,9 +25089,9 @@
             <a:prstDash val="solid"/>
           </a:ln>
           <a:effectLst>
-            <a:outerShdw sx="100000" sy="100000" kx="0" ky="0" algn="bl" rotWithShape="0" blurRad="Infinity" dist="Infinity" dir="Infinity">
+            <a:outerShdw sx="100000" sy="100000" kx="0" ky="0" algn="bl" rotWithShape="0" blurRad="88900" dist="25400" dir="5400000">
               <a:srgbClr val="9AB4CC">
-                <a:alpha val="Infinity"/>
+                <a:alpha val="30000"/>
               </a:srgbClr>
             </a:outerShdw>
           </a:effectLst>
@@ -25215,9 +25215,9 @@
             <a:prstDash val="solid"/>
           </a:ln>
           <a:effectLst>
-            <a:outerShdw sx="100000" sy="100000" kx="0" ky="0" algn="bl" rotWithShape="0" blurRad="Infinity" dist="Infinity" dir="Infinity">
+            <a:outerShdw sx="100000" sy="100000" kx="0" ky="0" algn="bl" rotWithShape="0" blurRad="88900" dist="25400" dir="5400000">
               <a:srgbClr val="9AB4CC">
-                <a:alpha val="Infinity"/>
+                <a:alpha val="30000"/>
               </a:srgbClr>
             </a:outerShdw>
           </a:effectLst>
@@ -25382,9 +25382,9 @@
             <a:prstDash val="solid"/>
           </a:ln>
           <a:effectLst>
-            <a:outerShdw sx="100000" sy="100000" kx="0" ky="0" algn="bl" rotWithShape="0" blurRad="Infinity" dist="Infinity" dir="Infinity">
+            <a:outerShdw sx="100000" sy="100000" kx="0" ky="0" algn="bl" rotWithShape="0" blurRad="88900" dist="25400" dir="5400000">
               <a:srgbClr val="9AB4CC">
-                <a:alpha val="Infinity"/>
+                <a:alpha val="30000"/>
               </a:srgbClr>
             </a:outerShdw>
           </a:effectLst>
@@ -25851,9 +25851,9 @@
             <a:prstDash val="solid"/>
           </a:ln>
           <a:effectLst>
-            <a:outerShdw sx="100000" sy="100000" kx="0" ky="0" algn="bl" rotWithShape="0" blurRad="Infinity" dist="Infinity" dir="Infinity">
+            <a:outerShdw sx="100000" sy="100000" kx="0" ky="0" algn="bl" rotWithShape="0" blurRad="88900" dist="25400" dir="5400000">
               <a:srgbClr val="9AB4CC">
-                <a:alpha val="Infinity"/>
+                <a:alpha val="30000"/>
               </a:srgbClr>
             </a:outerShdw>
           </a:effectLst>
@@ -25993,9 +25993,9 @@
             <a:prstDash val="solid"/>
           </a:ln>
           <a:effectLst>
-            <a:outerShdw sx="100000" sy="100000" kx="0" ky="0" algn="bl" rotWithShape="0" blurRad="Infinity" dist="Infinity" dir="Infinity">
+            <a:outerShdw sx="100000" sy="100000" kx="0" ky="0" algn="bl" rotWithShape="0" blurRad="88900" dist="25400" dir="5400000">
               <a:srgbClr val="9AB4CC">
-                <a:alpha val="Infinity"/>
+                <a:alpha val="30000"/>
               </a:srgbClr>
             </a:outerShdw>
           </a:effectLst>
@@ -26507,9 +26507,9 @@
             <a:prstDash val="solid"/>
           </a:ln>
           <a:effectLst>
-            <a:outerShdw sx="100000" sy="100000" kx="0" ky="0" algn="bl" rotWithShape="0" blurRad="Infinity" dist="Infinity" dir="Infinity">
+            <a:outerShdw sx="100000" sy="100000" kx="0" ky="0" algn="bl" rotWithShape="0" blurRad="88900" dist="25400" dir="5400000">
               <a:srgbClr val="9AB4CC">
-                <a:alpha val="Infinity"/>
+                <a:alpha val="30000"/>
               </a:srgbClr>
             </a:outerShdw>
           </a:effectLst>
@@ -26649,9 +26649,9 @@
             <a:prstDash val="solid"/>
           </a:ln>
           <a:effectLst>
-            <a:outerShdw sx="100000" sy="100000" kx="0" ky="0" algn="bl" rotWithShape="0" blurRad="Infinity" dist="Infinity" dir="Infinity">
+            <a:outerShdw sx="100000" sy="100000" kx="0" ky="0" algn="bl" rotWithShape="0" blurRad="88900" dist="25400" dir="5400000">
               <a:srgbClr val="9AB4CC">
-                <a:alpha val="Infinity"/>
+                <a:alpha val="30000"/>
               </a:srgbClr>
             </a:outerShdw>
           </a:effectLst>
@@ -26791,9 +26791,9 @@
             <a:prstDash val="solid"/>
           </a:ln>
           <a:effectLst>
-            <a:outerShdw sx="100000" sy="100000" kx="0" ky="0" algn="bl" rotWithShape="0" blurRad="Infinity" dist="Infinity" dir="Infinity">
+            <a:outerShdw sx="100000" sy="100000" kx="0" ky="0" algn="bl" rotWithShape="0" blurRad="88900" dist="25400" dir="5400000">
               <a:srgbClr val="9AB4CC">
-                <a:alpha val="Infinity"/>
+                <a:alpha val="30000"/>
               </a:srgbClr>
             </a:outerShdw>
           </a:effectLst>
@@ -27876,9 +27876,9 @@
             <a:prstDash val="solid"/>
           </a:ln>
           <a:effectLst>
-            <a:outerShdw sx="100000" sy="100000" kx="0" ky="0" algn="bl" rotWithShape="0" blurRad="Infinity" dist="Infinity" dir="Infinity">
+            <a:outerShdw sx="100000" sy="100000" kx="0" ky="0" algn="bl" rotWithShape="0" blurRad="88900" dist="25400" dir="5400000">
               <a:srgbClr val="9AB4CC">
-                <a:alpha val="Infinity"/>
+                <a:alpha val="30000"/>
               </a:srgbClr>
             </a:outerShdw>
           </a:effectLst>
@@ -28043,9 +28043,9 @@
             <a:prstDash val="solid"/>
           </a:ln>
           <a:effectLst>
-            <a:outerShdw sx="100000" sy="100000" kx="0" ky="0" algn="bl" rotWithShape="0" blurRad="Infinity" dist="Infinity" dir="Infinity">
+            <a:outerShdw sx="100000" sy="100000" kx="0" ky="0" algn="bl" rotWithShape="0" blurRad="88900" dist="25400" dir="5400000">
               <a:srgbClr val="9AB4CC">
-                <a:alpha val="Infinity"/>
+                <a:alpha val="30000"/>
               </a:srgbClr>
             </a:outerShdw>
           </a:effectLst>
@@ -28210,9 +28210,9 @@
             <a:prstDash val="solid"/>
           </a:ln>
           <a:effectLst>
-            <a:outerShdw sx="100000" sy="100000" kx="0" ky="0" algn="bl" rotWithShape="0" blurRad="Infinity" dist="Infinity" dir="Infinity">
+            <a:outerShdw sx="100000" sy="100000" kx="0" ky="0" algn="bl" rotWithShape="0" blurRad="88900" dist="25400" dir="5400000">
               <a:srgbClr val="9AB4CC">
-                <a:alpha val="Infinity"/>
+                <a:alpha val="30000"/>
               </a:srgbClr>
             </a:outerShdw>
           </a:effectLst>
@@ -28666,9 +28666,9 @@
             <a:prstDash val="solid"/>
           </a:ln>
           <a:effectLst>
-            <a:outerShdw sx="100000" sy="100000" kx="0" ky="0" algn="bl" rotWithShape="0" blurRad="Infinity" dist="Infinity" dir="Infinity">
+            <a:outerShdw sx="100000" sy="100000" kx="0" ky="0" algn="bl" rotWithShape="0" blurRad="88900" dist="25400" dir="5400000">
               <a:srgbClr val="9AB4CC">
-                <a:alpha val="Infinity"/>
+                <a:alpha val="30000"/>
               </a:srgbClr>
             </a:outerShdw>
           </a:effectLst>
@@ -28794,9 +28794,9 @@
             <a:prstDash val="solid"/>
           </a:ln>
           <a:effectLst>
-            <a:outerShdw sx="100000" sy="100000" kx="0" ky="0" algn="bl" rotWithShape="0" blurRad="Infinity" dist="Infinity" dir="Infinity">
+            <a:outerShdw sx="100000" sy="100000" kx="0" ky="0" algn="bl" rotWithShape="0" blurRad="88900" dist="25400" dir="5400000">
               <a:srgbClr val="9AB4CC">
-                <a:alpha val="Infinity"/>
+                <a:alpha val="30000"/>
               </a:srgbClr>
             </a:outerShdw>
           </a:effectLst>
@@ -28922,9 +28922,9 @@
             <a:prstDash val="solid"/>
           </a:ln>
           <a:effectLst>
-            <a:outerShdw sx="100000" sy="100000" kx="0" ky="0" algn="bl" rotWithShape="0" blurRad="Infinity" dist="Infinity" dir="Infinity">
+            <a:outerShdw sx="100000" sy="100000" kx="0" ky="0" algn="bl" rotWithShape="0" blurRad="88900" dist="25400" dir="5400000">
               <a:srgbClr val="9AB4CC">
-                <a:alpha val="Infinity"/>
+                <a:alpha val="30000"/>
               </a:srgbClr>
             </a:outerShdw>
           </a:effectLst>
@@ -29065,9 +29065,9 @@
             <a:prstDash val="solid"/>
           </a:ln>
           <a:effectLst>
-            <a:outerShdw sx="100000" sy="100000" kx="0" ky="0" algn="bl" rotWithShape="0" blurRad="Infinity" dist="Infinity" dir="Infinity">
+            <a:outerShdw sx="100000" sy="100000" kx="0" ky="0" algn="bl" rotWithShape="0" blurRad="88900" dist="25400" dir="5400000">
               <a:srgbClr val="9AB4CC">
-                <a:alpha val="Infinity"/>
+                <a:alpha val="30000"/>
               </a:srgbClr>
             </a:outerShdw>
           </a:effectLst>
@@ -29193,9 +29193,9 @@
             <a:prstDash val="solid"/>
           </a:ln>
           <a:effectLst>
-            <a:outerShdw sx="100000" sy="100000" kx="0" ky="0" algn="bl" rotWithShape="0" blurRad="Infinity" dist="Infinity" dir="Infinity">
+            <a:outerShdw sx="100000" sy="100000" kx="0" ky="0" algn="bl" rotWithShape="0" blurRad="88900" dist="25400" dir="5400000">
               <a:srgbClr val="9AB4CC">
-                <a:alpha val="Infinity"/>
+                <a:alpha val="30000"/>
               </a:srgbClr>
             </a:outerShdw>
           </a:effectLst>
@@ -29814,9 +29814,9 @@
             <a:prstDash val="solid"/>
           </a:ln>
           <a:effectLst>
-            <a:outerShdw sx="100000" sy="100000" kx="0" ky="0" algn="bl" rotWithShape="0" blurRad="Infinity" dist="Infinity" dir="Infinity">
+            <a:outerShdw sx="100000" sy="100000" kx="0" ky="0" algn="bl" rotWithShape="0" blurRad="88900" dist="25400" dir="5400000">
               <a:srgbClr val="9AB4CC">
-                <a:alpha val="Infinity"/>
+                <a:alpha val="30000"/>
               </a:srgbClr>
             </a:outerShdw>
           </a:effectLst>
@@ -29917,9 +29917,9 @@
             <a:prstDash val="solid"/>
           </a:ln>
           <a:effectLst>
-            <a:outerShdw sx="100000" sy="100000" kx="0" ky="0" algn="bl" rotWithShape="0" blurRad="Infinity" dist="Infinity" dir="Infinity">
+            <a:outerShdw sx="100000" sy="100000" kx="0" ky="0" algn="bl" rotWithShape="0" blurRad="88900" dist="25400" dir="5400000">
               <a:srgbClr val="9AB4CC">
-                <a:alpha val="Infinity"/>
+                <a:alpha val="30000"/>
               </a:srgbClr>
             </a:outerShdw>
           </a:effectLst>
@@ -30020,9 +30020,9 @@
             <a:prstDash val="solid"/>
           </a:ln>
           <a:effectLst>
-            <a:outerShdw sx="100000" sy="100000" kx="0" ky="0" algn="bl" rotWithShape="0" blurRad="Infinity" dist="Infinity" dir="Infinity">
+            <a:outerShdw sx="100000" sy="100000" kx="0" ky="0" algn="bl" rotWithShape="0" blurRad="88900" dist="25400" dir="5400000">
               <a:srgbClr val="9AB4CC">
-                <a:alpha val="Infinity"/>
+                <a:alpha val="30000"/>
               </a:srgbClr>
             </a:outerShdw>
           </a:effectLst>
@@ -30123,9 +30123,9 @@
             <a:prstDash val="solid"/>
           </a:ln>
           <a:effectLst>
-            <a:outerShdw sx="100000" sy="100000" kx="0" ky="0" algn="bl" rotWithShape="0" blurRad="Infinity" dist="Infinity" dir="Infinity">
+            <a:outerShdw sx="100000" sy="100000" kx="0" ky="0" algn="bl" rotWithShape="0" blurRad="88900" dist="25400" dir="5400000">
               <a:srgbClr val="9AB4CC">
-                <a:alpha val="Infinity"/>
+                <a:alpha val="30000"/>
               </a:srgbClr>
             </a:outerShdw>
           </a:effectLst>
@@ -30226,9 +30226,9 @@
             <a:prstDash val="solid"/>
           </a:ln>
           <a:effectLst>
-            <a:outerShdw sx="100000" sy="100000" kx="0" ky="0" algn="bl" rotWithShape="0" blurRad="Infinity" dist="Infinity" dir="Infinity">
+            <a:outerShdw sx="100000" sy="100000" kx="0" ky="0" algn="bl" rotWithShape="0" blurRad="88900" dist="25400" dir="5400000">
               <a:srgbClr val="9AB4CC">
-                <a:alpha val="Infinity"/>
+                <a:alpha val="30000"/>
               </a:srgbClr>
             </a:outerShdw>
           </a:effectLst>
@@ -30329,9 +30329,9 @@
             <a:prstDash val="solid"/>
           </a:ln>
           <a:effectLst>
-            <a:outerShdw sx="100000" sy="100000" kx="0" ky="0" algn="bl" rotWithShape="0" blurRad="Infinity" dist="Infinity" dir="Infinity">
+            <a:outerShdw sx="100000" sy="100000" kx="0" ky="0" algn="bl" rotWithShape="0" blurRad="88900" dist="25400" dir="5400000">
               <a:srgbClr val="9AB4CC">
-                <a:alpha val="Infinity"/>
+                <a:alpha val="30000"/>
               </a:srgbClr>
             </a:outerShdw>
           </a:effectLst>
@@ -30432,9 +30432,9 @@
             <a:prstDash val="solid"/>
           </a:ln>
           <a:effectLst>
-            <a:outerShdw sx="100000" sy="100000" kx="0" ky="0" algn="bl" rotWithShape="0" blurRad="Infinity" dist="Infinity" dir="Infinity">
+            <a:outerShdw sx="100000" sy="100000" kx="0" ky="0" algn="bl" rotWithShape="0" blurRad="88900" dist="25400" dir="5400000">
               <a:srgbClr val="9AB4CC">
-                <a:alpha val="Infinity"/>
+                <a:alpha val="30000"/>
               </a:srgbClr>
             </a:outerShdw>
           </a:effectLst>
@@ -32323,9 +32323,9 @@
             <a:prstDash val="solid"/>
           </a:ln>
           <a:effectLst>
-            <a:outerShdw sx="100000" sy="100000" kx="0" ky="0" algn="bl" rotWithShape="0" blurRad="Infinity" dist="Infinity" dir="Infinity">
+            <a:outerShdw sx="100000" sy="100000" kx="0" ky="0" algn="bl" rotWithShape="0" blurRad="88900" dist="25400" dir="5400000">
               <a:srgbClr val="9AB4CC">
-                <a:alpha val="Infinity"/>
+                <a:alpha val="30000"/>
               </a:srgbClr>
             </a:outerShdw>
           </a:effectLst>
@@ -32451,9 +32451,9 @@
             <a:prstDash val="solid"/>
           </a:ln>
           <a:effectLst>
-            <a:outerShdw sx="100000" sy="100000" kx="0" ky="0" algn="bl" rotWithShape="0" blurRad="Infinity" dist="Infinity" dir="Infinity">
+            <a:outerShdw sx="100000" sy="100000" kx="0" ky="0" algn="bl" rotWithShape="0" blurRad="88900" dist="25400" dir="5400000">
               <a:srgbClr val="9AB4CC">
-                <a:alpha val="Infinity"/>
+                <a:alpha val="30000"/>
               </a:srgbClr>
             </a:outerShdw>
           </a:effectLst>
@@ -32594,9 +32594,9 @@
             <a:prstDash val="solid"/>
           </a:ln>
           <a:effectLst>
-            <a:outerShdw sx="100000" sy="100000" kx="0" ky="0" algn="bl" rotWithShape="0" blurRad="Infinity" dist="Infinity" dir="Infinity">
+            <a:outerShdw sx="100000" sy="100000" kx="0" ky="0" algn="bl" rotWithShape="0" blurRad="88900" dist="25400" dir="5400000">
               <a:srgbClr val="9AB4CC">
-                <a:alpha val="Infinity"/>
+                <a:alpha val="30000"/>
               </a:srgbClr>
             </a:outerShdw>
           </a:effectLst>
@@ -32737,9 +32737,9 @@
             <a:prstDash val="solid"/>
           </a:ln>
           <a:effectLst>
-            <a:outerShdw sx="100000" sy="100000" kx="0" ky="0" algn="bl" rotWithShape="0" blurRad="Infinity" dist="Infinity" dir="Infinity">
+            <a:outerShdw sx="100000" sy="100000" kx="0" ky="0" algn="bl" rotWithShape="0" blurRad="88900" dist="25400" dir="5400000">
               <a:srgbClr val="9AB4CC">
-                <a:alpha val="Infinity"/>
+                <a:alpha val="30000"/>
               </a:srgbClr>
             </a:outerShdw>
           </a:effectLst>
@@ -32865,9 +32865,9 @@
             <a:prstDash val="solid"/>
           </a:ln>
           <a:effectLst>
-            <a:outerShdw sx="100000" sy="100000" kx="0" ky="0" algn="bl" rotWithShape="0" blurRad="Infinity" dist="Infinity" dir="Infinity">
+            <a:outerShdw sx="100000" sy="100000" kx="0" ky="0" algn="bl" rotWithShape="0" blurRad="88900" dist="25400" dir="5400000">
               <a:srgbClr val="9AB4CC">
-                <a:alpha val="Infinity"/>
+                <a:alpha val="30000"/>
               </a:srgbClr>
             </a:outerShdw>
           </a:effectLst>
@@ -32983,9 +32983,9 @@
             <a:prstDash val="solid"/>
           </a:ln>
           <a:effectLst>
-            <a:outerShdw sx="100000" sy="100000" kx="0" ky="0" algn="bl" rotWithShape="0" blurRad="Infinity" dist="Infinity" dir="Infinity">
+            <a:outerShdw sx="100000" sy="100000" kx="0" ky="0" algn="bl" rotWithShape="0" blurRad="88900" dist="25400" dir="5400000">
               <a:srgbClr val="9AB4CC">
-                <a:alpha val="Infinity"/>
+                <a:alpha val="30000"/>
               </a:srgbClr>
             </a:outerShdw>
           </a:effectLst>
@@ -33111,9 +33111,9 @@
             <a:prstDash val="solid"/>
           </a:ln>
           <a:effectLst>
-            <a:outerShdw sx="100000" sy="100000" kx="0" ky="0" algn="bl" rotWithShape="0" blurRad="Infinity" dist="Infinity" dir="Infinity">
+            <a:outerShdw sx="100000" sy="100000" kx="0" ky="0" algn="bl" rotWithShape="0" blurRad="88900" dist="25400" dir="5400000">
               <a:srgbClr val="9AB4CC">
-                <a:alpha val="Infinity"/>
+                <a:alpha val="30000"/>
               </a:srgbClr>
             </a:outerShdw>
           </a:effectLst>
@@ -33254,9 +33254,9 @@
             <a:prstDash val="solid"/>
           </a:ln>
           <a:effectLst>
-            <a:outerShdw sx="100000" sy="100000" kx="0" ky="0" algn="bl" rotWithShape="0" blurRad="Infinity" dist="Infinity" dir="Infinity">
+            <a:outerShdw sx="100000" sy="100000" kx="0" ky="0" algn="bl" rotWithShape="0" blurRad="88900" dist="25400" dir="5400000">
               <a:srgbClr val="9AB4CC">
-                <a:alpha val="Infinity"/>
+                <a:alpha val="30000"/>
               </a:srgbClr>
             </a:outerShdw>
           </a:effectLst>
@@ -33382,9 +33382,9 @@
             <a:prstDash val="solid"/>
           </a:ln>
           <a:effectLst>
-            <a:outerShdw sx="100000" sy="100000" kx="0" ky="0" algn="bl" rotWithShape="0" blurRad="Infinity" dist="Infinity" dir="Infinity">
+            <a:outerShdw sx="100000" sy="100000" kx="0" ky="0" algn="bl" rotWithShape="0" blurRad="88900" dist="25400" dir="5400000">
               <a:srgbClr val="9AB4CC">
-                <a:alpha val="Infinity"/>
+                <a:alpha val="30000"/>
               </a:srgbClr>
             </a:outerShdw>
           </a:effectLst>
@@ -33510,9 +33510,9 @@
             <a:prstDash val="solid"/>
           </a:ln>
           <a:effectLst>
-            <a:outerShdw sx="100000" sy="100000" kx="0" ky="0" algn="bl" rotWithShape="0" blurRad="Infinity" dist="Infinity" dir="Infinity">
+            <a:outerShdw sx="100000" sy="100000" kx="0" ky="0" algn="bl" rotWithShape="0" blurRad="88900" dist="25400" dir="5400000">
               <a:srgbClr val="9AB4CC">
-                <a:alpha val="Infinity"/>
+                <a:alpha val="30000"/>
               </a:srgbClr>
             </a:outerShdw>
           </a:effectLst>
@@ -33821,9 +33821,9 @@
             <a:prstDash val="solid"/>
           </a:ln>
           <a:effectLst>
-            <a:outerShdw sx="100000" sy="100000" kx="0" ky="0" algn="bl" rotWithShape="0" blurRad="6.016328324026578e+37" dist="1.7189509497218795e+37" dir="9.069926400000001e+44">
+            <a:outerShdw sx="100000" sy="100000" kx="0" ky="0" algn="bl" rotWithShape="0" blurRad="88900" dist="25400" dir="5400000">
               <a:srgbClr val="9AB4CC">
-                <a:alpha val="3e+44"/>
+                <a:alpha val="30000"/>
               </a:srgbClr>
             </a:outerShdw>
           </a:effectLst>
@@ -33988,9 +33988,9 @@
             <a:prstDash val="solid"/>
           </a:ln>
           <a:effectLst>
-            <a:outerShdw sx="100000" sy="100000" kx="0" ky="0" algn="bl" rotWithShape="0" blurRad="7.640736971513755e+41" dist="2.183067706146787e+41" dir="5.44195584e+49">
+            <a:outerShdw sx="100000" sy="100000" kx="0" ky="0" algn="bl" rotWithShape="0" blurRad="88900" dist="25400" dir="5400000">
               <a:srgbClr val="9AB4CC">
-                <a:alpha val="2.9999999999999997e+49"/>
+                <a:alpha val="30000"/>
               </a:srgbClr>
             </a:outerShdw>
           </a:effectLst>
@@ -34155,9 +34155,9 @@
             <a:prstDash val="solid"/>
           </a:ln>
           <a:effectLst>
-            <a:outerShdw sx="100000" sy="100000" kx="0" ky="0" algn="bl" rotWithShape="0" blurRad="9.703735953822469e+45" dist="2.7724959868064195e+45" dir="3.2651735040000005e+54">
+            <a:outerShdw sx="100000" sy="100000" kx="0" ky="0" algn="bl" rotWithShape="0" blurRad="88900" dist="25400" dir="5400000">
               <a:srgbClr val="9AB4CC">
-                <a:alpha val="2.9999999999999996e+54"/>
+                <a:alpha val="30000"/>
               </a:srgbClr>
             </a:outerShdw>
           </a:effectLst>
@@ -34797,9 +34797,9 @@
             <a:prstDash val="solid"/>
           </a:ln>
           <a:effectLst>
-            <a:outerShdw sx="100000" sy="100000" kx="0" ky="0" algn="bl" rotWithShape="0" blurRad="Infinity" dist="Infinity" dir="Infinity">
+            <a:outerShdw sx="100000" sy="100000" kx="0" ky="0" algn="bl" rotWithShape="0" blurRad="88900" dist="25400" dir="5400000">
               <a:srgbClr val="9AB4CC">
-                <a:alpha val="Infinity"/>
+                <a:alpha val="30000"/>
               </a:srgbClr>
             </a:outerShdw>
           </a:effectLst>
@@ -34967,9 +34967,9 @@
             <a:prstDash val="solid"/>
           </a:ln>
           <a:effectLst>
-            <a:outerShdw sx="100000" sy="100000" kx="0" ky="0" algn="bl" rotWithShape="0" blurRad="Infinity" dist="Infinity" dir="Infinity">
+            <a:outerShdw sx="100000" sy="100000" kx="0" ky="0" algn="bl" rotWithShape="0" blurRad="88900" dist="25400" dir="5400000">
               <a:srgbClr val="9AB4CC">
-                <a:alpha val="Infinity"/>
+                <a:alpha val="30000"/>
               </a:srgbClr>
             </a:outerShdw>
           </a:effectLst>
@@ -35758,9 +35758,9 @@
             <a:prstDash val="solid"/>
           </a:ln>
           <a:effectLst>
-            <a:outerShdw sx="100000" sy="100000" kx="0" ky="0" algn="bl" rotWithShape="0" blurRad="1.2323744661354536e+50" dist="3.5210699032441527e+49" dir="1.9591041024000004e+59">
+            <a:outerShdw sx="100000" sy="100000" kx="0" ky="0" algn="bl" rotWithShape="0" blurRad="88900" dist="25400" dir="5400000">
               <a:srgbClr val="9AB4CC">
-                <a:alpha val="2.9999999999999996e+59"/>
+                <a:alpha val="30000"/>
               </a:srgbClr>
             </a:outerShdw>
           </a:effectLst>
@@ -35925,9 +35925,9 @@
             <a:prstDash val="solid"/>
           </a:ln>
           <a:effectLst>
-            <a:outerShdw sx="100000" sy="100000" kx="0" ky="0" algn="bl" rotWithShape="0" blurRad="1.5651155719920262e+54" dist="4.471758777120074e+53" dir="1.1754624614400003e+64">
+            <a:outerShdw sx="100000" sy="100000" kx="0" ky="0" algn="bl" rotWithShape="0" blurRad="88900" dist="25400" dir="5400000">
               <a:srgbClr val="9AB4CC">
-                <a:alpha val="2.9999999999999996e+64"/>
+                <a:alpha val="30000"/>
               </a:srgbClr>
             </a:outerShdw>
           </a:effectLst>
@@ -36092,9 +36092,9 @@
             <a:prstDash val="solid"/>
           </a:ln>
           <a:effectLst>
-            <a:outerShdw sx="100000" sy="100000" kx="0" ky="0" algn="bl" rotWithShape="0" blurRad="1.9876967764298733e+58" dist="5.679133646942494e+57" dir="7.052774768640002e+68">
+            <a:outerShdw sx="100000" sy="100000" kx="0" ky="0" algn="bl" rotWithShape="0" blurRad="88900" dist="25400" dir="5400000">
               <a:srgbClr val="9AB4CC">
-                <a:alpha val="2.9999999999999995e+69"/>
+                <a:alpha val="30000"/>
               </a:srgbClr>
             </a:outerShdw>
           </a:effectLst>
@@ -36710,9 +36710,9 @@
             <a:prstDash val="solid"/>
           </a:ln>
           <a:effectLst>
-            <a:outerShdw sx="100000" sy="100000" kx="0" ky="0" algn="bl" rotWithShape="0" blurRad="2.524374906065939e+62" dist="7.212499731616968e+61" dir="4.2316648611840007e+73">
+            <a:outerShdw sx="100000" sy="100000" kx="0" ky="0" algn="bl" rotWithShape="0" blurRad="88900" dist="25400" dir="5400000">
               <a:srgbClr val="9AB4CC">
-                <a:alpha val="2.9999999999999995e+74"/>
+                <a:alpha val="30000"/>
               </a:srgbClr>
             </a:outerShdw>
           </a:effectLst>
@@ -36877,9 +36877,9 @@
             <a:prstDash val="solid"/>
           </a:ln>
           <a:effectLst>
-            <a:outerShdw sx="100000" sy="100000" kx="0" ky="0" algn="bl" rotWithShape="0" blurRad="3.2059561307037426e+66" dist="9.15987465915355e+65" dir="2.5389989167104004e+78">
+            <a:outerShdw sx="100000" sy="100000" kx="0" ky="0" algn="bl" rotWithShape="0" blurRad="88900" dist="25400" dir="5400000">
               <a:srgbClr val="9AB4CC">
-                <a:alpha val="3e+79"/>
+                <a:alpha val="30000"/>
               </a:srgbClr>
             </a:outerShdw>
           </a:effectLst>
@@ -37044,9 +37044,9 @@
             <a:prstDash val="solid"/>
           </a:ln>
           <a:effectLst>
-            <a:outerShdw sx="100000" sy="100000" kx="0" ky="0" algn="bl" rotWithShape="0" blurRad="4.071564285993753e+70" dist="1.1633040817125008e+70" dir="1.5233993500262402e+83">
+            <a:outerShdw sx="100000" sy="100000" kx="0" ky="0" algn="bl" rotWithShape="0" blurRad="88900" dist="25400" dir="5400000">
               <a:srgbClr val="9AB4CC">
-                <a:alpha val="2.9999999999999995e+84"/>
+                <a:alpha val="30000"/>
               </a:srgbClr>
             </a:outerShdw>
           </a:effectLst>
@@ -37796,9 +37796,9 @@
             <a:prstDash val="solid"/>
           </a:ln>
           <a:effectLst>
-            <a:outerShdw sx="100000" sy="100000" kx="0" ky="0" algn="bl" rotWithShape="0" blurRad="5.170886643212067e+74" dist="1.477396183774876e+74" dir="9.14039610015744e+87">
+            <a:outerShdw sx="100000" sy="100000" kx="0" ky="0" algn="bl" rotWithShape="0" blurRad="88900" dist="25400" dir="5400000">
               <a:srgbClr val="9AB4CC">
-                <a:alpha val="2.9999999999999996e+89"/>
+                <a:alpha val="30000"/>
               </a:srgbClr>
             </a:outerShdw>
           </a:effectLst>
@@ -37963,9 +37963,9 @@
             <a:prstDash val="solid"/>
           </a:ln>
           <a:effectLst>
-            <a:outerShdw sx="100000" sy="100000" kx="0" ky="0" algn="bl" rotWithShape="0" blurRad="6.567026036879325e+78" dist="1.8762931533940924e+78" dir="5.484237660094465e+92">
+            <a:outerShdw sx="100000" sy="100000" kx="0" ky="0" algn="bl" rotWithShape="0" blurRad="88900" dist="25400" dir="5400000">
               <a:srgbClr val="9AB4CC">
-                <a:alpha val="2.9999999999999997e+94"/>
+                <a:alpha val="30000"/>
               </a:srgbClr>
             </a:outerShdw>
           </a:effectLst>
@@ -38130,9 +38130,9 @@
             <a:prstDash val="solid"/>
           </a:ln>
           <a:effectLst>
-            <a:outerShdw sx="100000" sy="100000" kx="0" ky="0" algn="bl" rotWithShape="0" blurRad="8.340123066836742e+82" dist="2.3828923048104974e+82" dir="3.2905425960566786e+97">
+            <a:outerShdw sx="100000" sy="100000" kx="0" ky="0" algn="bl" rotWithShape="0" blurRad="88900" dist="25400" dir="5400000">
               <a:srgbClr val="9AB4CC">
-                <a:alpha val="2.9999999999999997e+99"/>
+                <a:alpha val="30000"/>
               </a:srgbClr>
             </a:outerShdw>
           </a:effectLst>
@@ -38624,9 +38624,9 @@
             <a:prstDash val="solid"/>
           </a:ln>
           <a:effectLst>
-            <a:outerShdw sx="100000" sy="100000" kx="0" ky="0" algn="bl" rotWithShape="0" blurRad="1.0591956294882662e+87" dist="3.0262732271093317e+86" dir="1.9743255576340073e+102">
+            <a:outerShdw sx="100000" sy="100000" kx="0" ky="0" algn="bl" rotWithShape="0" blurRad="88900" dist="25400" dir="5400000">
               <a:srgbClr val="9AB4CC">
-                <a:alpha val="3e+104"/>
+                <a:alpha val="30000"/>
               </a:srgbClr>
             </a:outerShdw>
           </a:effectLst>
@@ -38796,9 +38796,9 @@
             <a:prstDash val="solid"/>
           </a:ln>
           <a:effectLst>
-            <a:outerShdw sx="100000" sy="100000" kx="0" ky="0" algn="bl" rotWithShape="0" blurRad="1.3451784494500981e+91" dist="3.8433669984288512e+90" dir="1.1845953345804043e+107">
+            <a:outerShdw sx="100000" sy="100000" kx="0" ky="0" algn="bl" rotWithShape="0" blurRad="88900" dist="25400" dir="5400000">
               <a:srgbClr val="9AB4CC">
-                <a:alpha val="2.9999999999999997e+109"/>
+                <a:alpha val="30000"/>
               </a:srgbClr>
             </a:outerShdw>
           </a:effectLst>
@@ -38961,9 +38961,9 @@
             <a:prstDash val="solid"/>
           </a:ln>
           <a:effectLst>
-            <a:outerShdw sx="100000" sy="100000" kx="0" ky="0" algn="bl" rotWithShape="0" blurRad="1.7083766308016246e+95" dist="4.8810760880046414e+94" dir="7.107572007482426e+111">
+            <a:outerShdw sx="100000" sy="100000" kx="0" ky="0" algn="bl" rotWithShape="0" blurRad="88900" dist="25400" dir="5400000">
               <a:srgbClr val="9AB4CC">
-                <a:alpha val="2.9999999999999995e+114"/>
+                <a:alpha val="30000"/>
               </a:srgbClr>
             </a:outerShdw>
           </a:effectLst>
@@ -39126,9 +39126,9 @@
             <a:prstDash val="solid"/>
           </a:ln>
           <a:effectLst>
-            <a:outerShdw sx="100000" sy="100000" kx="0" ky="0" algn="bl" rotWithShape="0" blurRad="2.1696383211180632e+99" dist="6.198966631765894e+98" dir="4.2645432044894554e+116">
+            <a:outerShdw sx="100000" sy="100000" kx="0" ky="0" algn="bl" rotWithShape="0" blurRad="88900" dist="25400" dir="5400000">
               <a:srgbClr val="9AB4CC">
-                <a:alpha val="2.9999999999999997e+119"/>
+                <a:alpha val="30000"/>
               </a:srgbClr>
             </a:outerShdw>
           </a:effectLst>
@@ -39620,9 +39620,9 @@
             <a:prstDash val="solid"/>
           </a:ln>
           <a:effectLst>
-            <a:outerShdw sx="100000" sy="100000" kx="0" ky="0" algn="bl" rotWithShape="0" blurRad="2.7554406678199403e+103" dist="7.872687622342685e+102" dir="2.5587259226936733e+121">
+            <a:outerShdw sx="100000" sy="100000" kx="0" ky="0" algn="bl" rotWithShape="0" blurRad="88900" dist="25400" dir="5400000">
               <a:srgbClr val="9AB4CC">
-                <a:alpha val="2.9999999999999995e+124"/>
+                <a:alpha val="30000"/>
               </a:srgbClr>
             </a:outerShdw>
           </a:effectLst>
@@ -39787,9 +39787,9 @@
             <a:prstDash val="solid"/>
           </a:ln>
           <a:effectLst>
-            <a:outerShdw sx="100000" sy="100000" kx="0" ky="0" algn="bl" rotWithShape="0" blurRad="3.499409648131324e+107" dist="9.998313280375211e+106" dir="1.535235553616204e+126">
+            <a:outerShdw sx="100000" sy="100000" kx="0" ky="0" algn="bl" rotWithShape="0" blurRad="88900" dist="25400" dir="5400000">
               <a:srgbClr val="9AB4CC">
-                <a:alpha val="2.9999999999999997e+129"/>
+                <a:alpha val="30000"/>
               </a:srgbClr>
             </a:outerShdw>
           </a:effectLst>
@@ -39954,9 +39954,9 @@
             <a:prstDash val="solid"/>
           </a:ln>
           <a:effectLst>
-            <a:outerShdw sx="100000" sy="100000" kx="0" ky="0" algn="bl" rotWithShape="0" blurRad="4.4442502531267815e+111" dist="1.2697857866076517e+111" dir="9.211413321697224e+130">
+            <a:outerShdw sx="100000" sy="100000" kx="0" ky="0" algn="bl" rotWithShape="0" blurRad="88900" dist="25400" dir="5400000">
               <a:srgbClr val="9AB4CC">
-                <a:alpha val="2.9999999999999996e+134"/>
+                <a:alpha val="30000"/>
               </a:srgbClr>
             </a:outerShdw>
           </a:effectLst>

</xml_diff>